<commit_message>
Update PowerPoint for song #180 in FUBC - Українські
</commit_message>
<xml_diff>
--- a/fubc-ua/180-Тебе я славлю, Спасе мій (Пісні Спасенних №178).pptx
+++ b/fubc-ua/180-Тебе я славлю, Спасе мій (Пісні Спасенних №178).pptx
@@ -1535,23 +1535,6 @@
             </a:r>
             <a:endParaRPr lang="en-US" sz="5200" dirty="0"/>
           </a:p>
-          <a:p>
-            <a:pPr algn="ctr" indent="0" marL="0">
-              <a:buNone/>
-            </a:pPr>
-            <a:r>
-              <a:rPr lang="en-US" sz="5200" b="1" dirty="0">
-                <a:solidFill>
-                  <a:srgbClr val="FFFFFF"/>
-                </a:solidFill>
-                <a:latin typeface="Arial" pitchFamily="34" charset="0"/>
-                <a:ea typeface="Arial" pitchFamily="34" charset="-122"/>
-                <a:cs typeface="Arial" pitchFamily="34" charset="-120"/>
-              </a:rPr>
-              <a:t>(Пісні Спасенних №178)</a:t>
-            </a:r>
-            <a:endParaRPr lang="en-US" sz="5200" dirty="0"/>
-          </a:p>
         </p:txBody>
       </p:sp>
     </p:spTree>
@@ -1804,7 +1787,7 @@
                 <a:ea typeface="Arial" pitchFamily="34" charset="-122"/>
                 <a:cs typeface="Arial" pitchFamily="34" charset="-120"/>
               </a:rPr>
-              <a:t>Нове все (все нове),</a:t>
+              <a:t>Нове все, нове все!</a:t>
             </a:r>
             <a:endParaRPr lang="en-US" sz="5200" dirty="0"/>
           </a:p>
@@ -1824,7 +1807,7 @@
                 <a:ea typeface="Arial" pitchFamily="34" charset="-122"/>
                 <a:cs typeface="Arial" pitchFamily="34" charset="-120"/>
               </a:rPr>
-              <a:t>нове все (все нове)!</a:t>
+              <a:t>О, кров Христа мене спасла</a:t>
             </a:r>
             <a:endParaRPr lang="en-US" sz="5200" dirty="0"/>
           </a:p>
@@ -1844,26 +1827,6 @@
                 <a:ea typeface="Arial" pitchFamily="34" charset="-122"/>
                 <a:cs typeface="Arial" pitchFamily="34" charset="-120"/>
               </a:rPr>
-              <a:t>О, кров Христа мене спасла</a:t>
-            </a:r>
-            <a:endParaRPr lang="en-US" sz="5200" dirty="0"/>
-          </a:p>
-          <a:p>
-            <a:pPr algn="ctr" indent="0" marL="0">
-              <a:lnSpc>
-                <a:spcPts val="6200"/>
-              </a:lnSpc>
-              <a:buNone/>
-            </a:pPr>
-            <a:r>
-              <a:rPr lang="en-US" sz="5200" b="1" i="1" dirty="0">
-                <a:solidFill>
-                  <a:srgbClr val="FFFFFF"/>
-                </a:solidFill>
-                <a:latin typeface="Arial" pitchFamily="34" charset="0"/>
-                <a:ea typeface="Arial" pitchFamily="34" charset="-122"/>
-                <a:cs typeface="Arial" pitchFamily="34" charset="-120"/>
-              </a:rPr>
               <a:t>і все нове дала!</a:t>
             </a:r>
             <a:endParaRPr lang="en-US" sz="5200" dirty="0"/>
@@ -1878,7 +1841,7 @@
         </p:nvSpPr>
         <p:spPr>
           <a:xfrm>
-            <a:off x="1080999" y="774192"/>
+            <a:off x="1080999" y="1170432"/>
             <a:ext cx="0" cy="594360"/>
           </a:xfrm>
           <a:prstGeom prst="line">
@@ -1901,7 +1864,7 @@
         </p:nvSpPr>
         <p:spPr>
           <a:xfrm>
-            <a:off x="11117097" y="774192"/>
+            <a:off x="11117097" y="1170432"/>
             <a:ext cx="0" cy="594360"/>
           </a:xfrm>
           <a:prstGeom prst="line">
@@ -1924,7 +1887,7 @@
         </p:nvSpPr>
         <p:spPr>
           <a:xfrm>
-            <a:off x="11249177" y="840232"/>
+            <a:off x="11249177" y="1236472"/>
             <a:ext cx="792480" cy="462280"/>
           </a:xfrm>
           <a:prstGeom prst="rect">
@@ -2205,7 +2168,7 @@
                 <a:ea typeface="Arial" pitchFamily="34" charset="-122"/>
                 <a:cs typeface="Arial" pitchFamily="34" charset="-120"/>
               </a:rPr>
-              <a:t>Нове все (все нове),</a:t>
+              <a:t>Нове все, нове все!</a:t>
             </a:r>
             <a:endParaRPr lang="en-US" sz="5200" dirty="0"/>
           </a:p>
@@ -2225,7 +2188,7 @@
                 <a:ea typeface="Arial" pitchFamily="34" charset="-122"/>
                 <a:cs typeface="Arial" pitchFamily="34" charset="-120"/>
               </a:rPr>
-              <a:t>нове все (все нове)!</a:t>
+              <a:t>О, кров Христа мене спасла</a:t>
             </a:r>
             <a:endParaRPr lang="en-US" sz="5200" dirty="0"/>
           </a:p>
@@ -2245,26 +2208,6 @@
                 <a:ea typeface="Arial" pitchFamily="34" charset="-122"/>
                 <a:cs typeface="Arial" pitchFamily="34" charset="-120"/>
               </a:rPr>
-              <a:t>О, кров Христа мене спасла</a:t>
-            </a:r>
-            <a:endParaRPr lang="en-US" sz="5200" dirty="0"/>
-          </a:p>
-          <a:p>
-            <a:pPr algn="ctr" indent="0" marL="0">
-              <a:lnSpc>
-                <a:spcPts val="6200"/>
-              </a:lnSpc>
-              <a:buNone/>
-            </a:pPr>
-            <a:r>
-              <a:rPr lang="en-US" sz="5200" b="1" i="1" dirty="0">
-                <a:solidFill>
-                  <a:srgbClr val="FFFFFF"/>
-                </a:solidFill>
-                <a:latin typeface="Arial" pitchFamily="34" charset="0"/>
-                <a:ea typeface="Arial" pitchFamily="34" charset="-122"/>
-                <a:cs typeface="Arial" pitchFamily="34" charset="-120"/>
-              </a:rPr>
               <a:t>і все нове дала!</a:t>
             </a:r>
             <a:endParaRPr lang="en-US" sz="5200" dirty="0"/>
@@ -2279,7 +2222,7 @@
         </p:nvSpPr>
         <p:spPr>
           <a:xfrm>
-            <a:off x="1080999" y="774192"/>
+            <a:off x="1080999" y="1170432"/>
             <a:ext cx="0" cy="594360"/>
           </a:xfrm>
           <a:prstGeom prst="line">
@@ -2302,7 +2245,7 @@
         </p:nvSpPr>
         <p:spPr>
           <a:xfrm>
-            <a:off x="11117097" y="774192"/>
+            <a:off x="11117097" y="1170432"/>
             <a:ext cx="0" cy="594360"/>
           </a:xfrm>
           <a:prstGeom prst="line">
@@ -2325,7 +2268,7 @@
         </p:nvSpPr>
         <p:spPr>
           <a:xfrm>
-            <a:off x="11249177" y="840232"/>
+            <a:off x="11249177" y="1236472"/>
             <a:ext cx="792480" cy="462280"/>
           </a:xfrm>
           <a:prstGeom prst="rect">
@@ -2606,7 +2549,7 @@
                 <a:ea typeface="Arial" pitchFamily="34" charset="-122"/>
                 <a:cs typeface="Arial" pitchFamily="34" charset="-120"/>
               </a:rPr>
-              <a:t>Нове все (все нове),</a:t>
+              <a:t>Нове все, нове все!</a:t>
             </a:r>
             <a:endParaRPr lang="en-US" sz="5200" dirty="0"/>
           </a:p>
@@ -2626,7 +2569,7 @@
                 <a:ea typeface="Arial" pitchFamily="34" charset="-122"/>
                 <a:cs typeface="Arial" pitchFamily="34" charset="-120"/>
               </a:rPr>
-              <a:t>нове все (все нове)!</a:t>
+              <a:t>О, кров Христа мене спасла</a:t>
             </a:r>
             <a:endParaRPr lang="en-US" sz="5200" dirty="0"/>
           </a:p>
@@ -2646,26 +2589,6 @@
                 <a:ea typeface="Arial" pitchFamily="34" charset="-122"/>
                 <a:cs typeface="Arial" pitchFamily="34" charset="-120"/>
               </a:rPr>
-              <a:t>О, кров Христа мене спасла</a:t>
-            </a:r>
-            <a:endParaRPr lang="en-US" sz="5200" dirty="0"/>
-          </a:p>
-          <a:p>
-            <a:pPr algn="ctr" indent="0" marL="0">
-              <a:lnSpc>
-                <a:spcPts val="6200"/>
-              </a:lnSpc>
-              <a:buNone/>
-            </a:pPr>
-            <a:r>
-              <a:rPr lang="en-US" sz="5200" b="1" i="1" dirty="0">
-                <a:solidFill>
-                  <a:srgbClr val="FFFFFF"/>
-                </a:solidFill>
-                <a:latin typeface="Arial" pitchFamily="34" charset="0"/>
-                <a:ea typeface="Arial" pitchFamily="34" charset="-122"/>
-                <a:cs typeface="Arial" pitchFamily="34" charset="-120"/>
-              </a:rPr>
               <a:t>і все нове дала!</a:t>
             </a:r>
             <a:endParaRPr lang="en-US" sz="5200" dirty="0"/>
@@ -2680,7 +2603,7 @@
         </p:nvSpPr>
         <p:spPr>
           <a:xfrm>
-            <a:off x="1080999" y="774192"/>
+            <a:off x="1080999" y="1170432"/>
             <a:ext cx="0" cy="594360"/>
           </a:xfrm>
           <a:prstGeom prst="line">
@@ -2703,7 +2626,7 @@
         </p:nvSpPr>
         <p:spPr>
           <a:xfrm>
-            <a:off x="11117097" y="774192"/>
+            <a:off x="11117097" y="1170432"/>
             <a:ext cx="0" cy="594360"/>
           </a:xfrm>
           <a:prstGeom prst="line">
@@ -2726,7 +2649,7 @@
         </p:nvSpPr>
         <p:spPr>
           <a:xfrm>
-            <a:off x="11249177" y="840232"/>
+            <a:off x="11249177" y="1236472"/>
             <a:ext cx="792480" cy="462280"/>
           </a:xfrm>
           <a:prstGeom prst="rect">

</xml_diff>